<commit_message>
feat: scope support agents to their assigned projects (decision I)
Agents now see only tickets for the client companies they cover (new
AGENT_COMPANIES bridge table) instead of every client's open queue.
The 4 roles are unchanged: Manager, L1/L2/L3 tiers, and Project Lead
are NOT separate roles (overseer behaviour, Escalate action, and a
deferred is_lead flag respectively).

Synced across every artifact: brief, visual HTML, kickoff deck,
requirements tracker, page-build-guide (7-table schema + AGENT_COMPANIES,
the visibility predicate in all 5 places, and the Page 10a admin grid),
CLAUDE.md, and the tenant-isolation-auditor agent.
</commit_message>
<xml_diff>
--- a/docs/Ticketing-Kickoff.pptx
+++ b/docs/Ticketing-Kickoff.pptx
@@ -5238,7 +5238,7 @@
                 </a:solidFill>
                 <a:latin typeface="Calibri"/>
               </a:rPr>
-              <a:t>• A · Agent self-assigns, or only Admin assigns?  → Admin assigns</a:t>
+              <a:t>• A · Agent self-assigns, or only Admin assigns?  → CONFIRMED: both — agents self-assign + Admin assigns/reassigns</a:t>
             </a:r>
           </a:p>
           <a:p>
@@ -5351,6 +5351,22 @@
                 <a:latin typeface="Calibri"/>
               </a:rPr>
               <a:t>• H · Adopt the 4 new SHOULD items (CSAT, analytics, auto-ack, escalate)?  → Yes</a:t>
+            </a:r>
+          </a:p>
+          <a:p>
+            <a:pPr>
+              <a:spcAft>
+                <a:spcPts val="1400"/>
+              </a:spcAft>
+            </a:pPr>
+            <a:r>
+              <a:rPr sz="2000" b="0">
+                <a:solidFill>
+                  <a:srgbClr val="1F3864"/>
+                </a:solidFill>
+                <a:latin typeface="Calibri"/>
+              </a:rPr>
+              <a:t>• I · Agents see all clients, or only their projects?  → Scoped to assigned projects</a:t>
             </a:r>
           </a:p>
         </p:txBody>
@@ -7084,7 +7100,7 @@
                 </a:solidFill>
                 <a:latin typeface="Calibri"/>
               </a:rPr>
-              <a:t>Works assigned tickets: status, comments, resolve.</a:t>
+              <a:t>Works tickets for their ASSIGNED PROJECTS only (clients they cover): status, comments, resolve.</a:t>
             </a:r>
           </a:p>
         </p:txBody>
@@ -9962,7 +9978,7 @@
                 </a:solidFill>
                 <a:latin typeface="Calibri"/>
               </a:rPr>
-              <a:t>Data model (6 tables)</a:t>
+              <a:t>Data model (7 tables)</a:t>
             </a:r>
           </a:p>
         </p:txBody>
@@ -10010,8 +10026,8 @@
         </p:nvSpPr>
         <p:spPr>
           <a:xfrm>
-            <a:off x="640080" y="1417320"/>
-            <a:ext cx="2926080" cy="658368"/>
+            <a:off x="640080" y="1371600"/>
+            <a:ext cx="2926080" cy="603504"/>
           </a:xfrm>
           <a:prstGeom prst="rect">
             <a:avLst/>
@@ -10054,7 +10070,7 @@
         </p:nvSpPr>
         <p:spPr>
           <a:xfrm>
-            <a:off x="731520" y="1536192"/>
+            <a:off x="731520" y="1490472"/>
             <a:ext cx="2743200" cy="457200"/>
           </a:xfrm>
           <a:prstGeom prst="rect">
@@ -10089,7 +10105,7 @@
         </p:nvSpPr>
         <p:spPr>
           <a:xfrm>
-            <a:off x="3749039" y="1463040"/>
+            <a:off x="3749039" y="1417320"/>
             <a:ext cx="7863840" cy="566928"/>
           </a:xfrm>
           <a:prstGeom prst="rect">
@@ -10124,8 +10140,8 @@
         </p:nvSpPr>
         <p:spPr>
           <a:xfrm>
-            <a:off x="640080" y="2167128"/>
-            <a:ext cx="2926080" cy="658368"/>
+            <a:off x="640080" y="2029967"/>
+            <a:ext cx="2926080" cy="603504"/>
           </a:xfrm>
           <a:prstGeom prst="rect">
             <a:avLst/>
@@ -10168,7 +10184,7 @@
         </p:nvSpPr>
         <p:spPr>
           <a:xfrm>
-            <a:off x="731520" y="2286000"/>
+            <a:off x="731520" y="2148839"/>
             <a:ext cx="2743200" cy="457200"/>
           </a:xfrm>
           <a:prstGeom prst="rect">
@@ -10203,7 +10219,7 @@
         </p:nvSpPr>
         <p:spPr>
           <a:xfrm>
-            <a:off x="3749039" y="2212848"/>
+            <a:off x="3749039" y="2075687"/>
             <a:ext cx="7863840" cy="566928"/>
           </a:xfrm>
           <a:prstGeom prst="rect">
@@ -10238,8 +10254,8 @@
         </p:nvSpPr>
         <p:spPr>
           <a:xfrm>
-            <a:off x="640080" y="2916936"/>
-            <a:ext cx="2926080" cy="658368"/>
+            <a:off x="640080" y="2688336"/>
+            <a:ext cx="2926080" cy="603504"/>
           </a:xfrm>
           <a:prstGeom prst="rect">
             <a:avLst/>
@@ -10282,7 +10298,7 @@
         </p:nvSpPr>
         <p:spPr>
           <a:xfrm>
-            <a:off x="731520" y="3035808"/>
+            <a:off x="731520" y="2807208"/>
             <a:ext cx="2743200" cy="457200"/>
           </a:xfrm>
           <a:prstGeom prst="rect">
@@ -10317,7 +10333,7 @@
         </p:nvSpPr>
         <p:spPr>
           <a:xfrm>
-            <a:off x="3749039" y="2962656"/>
+            <a:off x="3749039" y="2734056"/>
             <a:ext cx="7863840" cy="566928"/>
           </a:xfrm>
           <a:prstGeom prst="rect">
@@ -10352,8 +10368,8 @@
         </p:nvSpPr>
         <p:spPr>
           <a:xfrm>
-            <a:off x="640080" y="3666744"/>
-            <a:ext cx="2926080" cy="658368"/>
+            <a:off x="640080" y="3346704"/>
+            <a:ext cx="2926080" cy="603504"/>
           </a:xfrm>
           <a:prstGeom prst="rect">
             <a:avLst/>
@@ -10396,7 +10412,7 @@
         </p:nvSpPr>
         <p:spPr>
           <a:xfrm>
-            <a:off x="731520" y="3785616"/>
+            <a:off x="731520" y="3465576"/>
             <a:ext cx="2743200" cy="457200"/>
           </a:xfrm>
           <a:prstGeom prst="rect">
@@ -10431,7 +10447,7 @@
         </p:nvSpPr>
         <p:spPr>
           <a:xfrm>
-            <a:off x="3749039" y="3712464"/>
+            <a:off x="3749039" y="3392424"/>
             <a:ext cx="7863840" cy="566928"/>
           </a:xfrm>
           <a:prstGeom prst="rect">
@@ -10466,8 +10482,8 @@
         </p:nvSpPr>
         <p:spPr>
           <a:xfrm>
-            <a:off x="640080" y="4416552"/>
-            <a:ext cx="2926080" cy="658368"/>
+            <a:off x="640080" y="4005072"/>
+            <a:ext cx="2926080" cy="603504"/>
           </a:xfrm>
           <a:prstGeom prst="rect">
             <a:avLst/>
@@ -10510,7 +10526,7 @@
         </p:nvSpPr>
         <p:spPr>
           <a:xfrm>
-            <a:off x="731520" y="4535424"/>
+            <a:off x="731520" y="4123944"/>
             <a:ext cx="2743200" cy="457200"/>
           </a:xfrm>
           <a:prstGeom prst="rect">
@@ -10545,7 +10561,7 @@
         </p:nvSpPr>
         <p:spPr>
           <a:xfrm>
-            <a:off x="3749039" y="4462272"/>
+            <a:off x="3749039" y="4050791"/>
             <a:ext cx="7863840" cy="566928"/>
           </a:xfrm>
           <a:prstGeom prst="rect">
@@ -10580,8 +10596,8 @@
         </p:nvSpPr>
         <p:spPr>
           <a:xfrm>
-            <a:off x="640080" y="5166360"/>
-            <a:ext cx="2926080" cy="658368"/>
+            <a:off x="640080" y="4663440"/>
+            <a:ext cx="2926080" cy="603504"/>
           </a:xfrm>
           <a:prstGeom prst="rect">
             <a:avLst/>
@@ -10624,7 +10640,7 @@
         </p:nvSpPr>
         <p:spPr>
           <a:xfrm>
-            <a:off x="731520" y="5285232"/>
+            <a:off x="731520" y="4782312"/>
             <a:ext cx="2743200" cy="457200"/>
           </a:xfrm>
           <a:prstGeom prst="rect">
@@ -10659,7 +10675,7 @@
         </p:nvSpPr>
         <p:spPr>
           <a:xfrm>
-            <a:off x="3749039" y="5212080"/>
+            <a:off x="3749039" y="4709159"/>
             <a:ext cx="7863840" cy="566928"/>
           </a:xfrm>
           <a:prstGeom prst="rect">
@@ -10716,7 +10732,7 @@
                 </a:solidFill>
                 <a:latin typeface="Calibri"/>
               </a:rPr>
-              <a:t>Every ticket carries a company_id — that column is how we keep clients isolated.</a:t>
+              <a:t>Every ticket carries a company_id — that keeps clients isolated. Agents are further scoped to their projects via AGENT_COMPANIES.</a:t>
             </a:r>
           </a:p>
         </p:txBody>
@@ -10787,6 +10803,120 @@
                 <a:latin typeface="Calibri"/>
               </a:rPr>
               <a:t>8</a:t>
+            </a:r>
+          </a:p>
+        </p:txBody>
+      </p:sp>
+      <p:sp>
+        <p:nvSpPr>
+          <p:cNvPr id="21" name="Rectangle 20"/>
+          <p:cNvSpPr/>
+          <p:nvPr/>
+        </p:nvSpPr>
+        <p:spPr>
+          <a:xfrm>
+            <a:off x="640080" y="5321808"/>
+            <a:ext cx="2926080" cy="603504"/>
+          </a:xfrm>
+          <a:prstGeom prst="rect">
+            <a:avLst/>
+          </a:prstGeom>
+          <a:solidFill>
+            <a:srgbClr val="2E5496"/>
+          </a:solidFill>
+          <a:ln>
+            <a:noFill/>
+          </a:ln>
+          <a:effectLst/>
+        </p:spPr>
+        <p:style>
+          <a:lnRef idx="1">
+            <a:schemeClr val="accent1"/>
+          </a:lnRef>
+          <a:fillRef idx="3">
+            <a:schemeClr val="accent1"/>
+          </a:fillRef>
+          <a:effectRef idx="2">
+            <a:schemeClr val="accent1"/>
+          </a:effectRef>
+          <a:fontRef idx="minor">
+            <a:schemeClr val="lt1"/>
+          </a:fontRef>
+        </p:style>
+        <p:txBody>
+          <a:bodyPr rtlCol="0" anchor="ctr"/>
+          <a:lstStyle/>
+          <a:p>
+            <a:pPr algn="ctr"/>
+          </a:p>
+        </p:txBody>
+      </p:sp>
+      <p:sp>
+        <p:nvSpPr>
+          <p:cNvPr id="22" name="TextBox 21"/>
+          <p:cNvSpPr txBox="1"/>
+          <p:nvPr/>
+        </p:nvSpPr>
+        <p:spPr>
+          <a:xfrm>
+            <a:off x="731520" y="5440680"/>
+            <a:ext cx="2743200" cy="457200"/>
+          </a:xfrm>
+          <a:prstGeom prst="rect">
+            <a:avLst/>
+          </a:prstGeom>
+          <a:noFill/>
+        </p:spPr>
+        <p:txBody>
+          <a:bodyPr wrap="square" anchor="t">
+            <a:spAutoFit/>
+          </a:bodyPr>
+          <a:lstStyle/>
+          <a:p>
+            <a:pPr algn="l"/>
+            <a:r>
+              <a:rPr sz="1600" b="1" i="0">
+                <a:solidFill>
+                  <a:srgbClr val="FFFFFF"/>
+                </a:solidFill>
+                <a:latin typeface="Calibri"/>
+              </a:rPr>
+              <a:t>AGENT_COMPANIES</a:t>
+            </a:r>
+          </a:p>
+        </p:txBody>
+      </p:sp>
+      <p:sp>
+        <p:nvSpPr>
+          <p:cNvPr id="23" name="TextBox 22"/>
+          <p:cNvSpPr txBox="1"/>
+          <p:nvPr/>
+        </p:nvSpPr>
+        <p:spPr>
+          <a:xfrm>
+            <a:off x="3749039" y="5367528"/>
+            <a:ext cx="7863840" cy="566928"/>
+          </a:xfrm>
+          <a:prstGeom prst="rect">
+            <a:avLst/>
+          </a:prstGeom>
+          <a:noFill/>
+        </p:spPr>
+        <p:txBody>
+          <a:bodyPr wrap="square" anchor="ctr">
+            <a:spAutoFit/>
+          </a:bodyPr>
+          <a:lstStyle/>
+          <a:p>
+            <a:pPr algn="l"/>
+            <a:r>
+              <a:rPr sz="1700" b="0" i="0">
+                <a:solidFill>
+                  <a:srgbClr val="1F3864"/>
+                </a:solidFill>
+                <a:latin typeface="Calibri"/>
+              </a:rPr>
+              <a:t>which clients (projects) each agent covers</a:t>
             </a:r>
           </a:p>
         </p:txBody>

</xml_diff>

<commit_message>
docs: add ticket aging (stale/overdue) build recipe + sync project docs
- page-build-guide: new 'Ticket aging' add-on section (stale flag + overdue
  highlight) with role-aware §A.7 predicate, declarative IR highlight steps,
  CSS, and per-role isolation tests; reviewed by tenant-isolation-auditor
- page-build-guide: align *_AT/SLA_DUE columns to TIMESTAMP WITH LOCAL TIME ZONE
- brief: add timestamps & history-vocabulary convention (enables aging/FRT
  metrics with no schema change); fix reopen-detection note
- include pre-existing doc/tooling updates (READMEs, deck/sheet, sync-docs)
</commit_message>
<xml_diff>
--- a/docs/Ticketing-Kickoff.pptx
+++ b/docs/Ticketing-Kickoff.pptx
@@ -8211,7 +8211,7 @@
         <p:spPr>
           <a:xfrm>
             <a:off x="640080" y="1371600"/>
-            <a:ext cx="3611880" cy="640080"/>
+            <a:ext cx="2592883" cy="640080"/>
           </a:xfrm>
           <a:prstGeom prst="rect">
             <a:avLst/>
@@ -8255,7 +8255,7 @@
         <p:spPr>
           <a:xfrm>
             <a:off x="640080" y="1426464"/>
-            <a:ext cx="3611880" cy="548640"/>
+            <a:ext cx="2592883" cy="548640"/>
           </a:xfrm>
           <a:prstGeom prst="rect">
             <a:avLst/>
@@ -8290,7 +8290,7 @@
         <p:spPr>
           <a:xfrm>
             <a:off x="640080" y="2057400"/>
-            <a:ext cx="3611880" cy="365760"/>
+            <a:ext cx="2592883" cy="365760"/>
           </a:xfrm>
           <a:prstGeom prst="rect">
             <a:avLst/>
@@ -8325,7 +8325,7 @@
         <p:spPr>
           <a:xfrm>
             <a:off x="777240" y="2560320"/>
-            <a:ext cx="3337560" cy="3657600"/>
+            <a:ext cx="2318563" cy="3657600"/>
           </a:xfrm>
           <a:prstGeom prst="rect">
             <a:avLst/>
@@ -8443,8 +8443,8 @@
         </p:nvSpPr>
         <p:spPr>
           <a:xfrm>
-            <a:off x="4434840" y="1371600"/>
-            <a:ext cx="3611880" cy="640080"/>
+            <a:off x="3412963" y="1371600"/>
+            <a:ext cx="2592883" cy="640080"/>
           </a:xfrm>
           <a:prstGeom prst="rect">
             <a:avLst/>
@@ -8487,8 +8487,8 @@
         </p:nvSpPr>
         <p:spPr>
           <a:xfrm>
-            <a:off x="4434840" y="1426464"/>
-            <a:ext cx="3611880" cy="548640"/>
+            <a:off x="3412963" y="1426464"/>
+            <a:ext cx="2592883" cy="548640"/>
           </a:xfrm>
           <a:prstGeom prst="rect">
             <a:avLst/>
@@ -8522,8 +8522,8 @@
         </p:nvSpPr>
         <p:spPr>
           <a:xfrm>
-            <a:off x="4434840" y="2057400"/>
-            <a:ext cx="3611880" cy="365760"/>
+            <a:off x="3412963" y="2057400"/>
+            <a:ext cx="2592883" cy="365760"/>
           </a:xfrm>
           <a:prstGeom prst="rect">
             <a:avLst/>
@@ -8557,8 +8557,8 @@
         </p:nvSpPr>
         <p:spPr>
           <a:xfrm>
-            <a:off x="4572000" y="2560320"/>
-            <a:ext cx="3337560" cy="3657600"/>
+            <a:off x="3550123" y="2560320"/>
+            <a:ext cx="2318563" cy="3657600"/>
           </a:xfrm>
           <a:prstGeom prst="rect">
             <a:avLst/>
@@ -8708,8 +8708,8 @@
         </p:nvSpPr>
         <p:spPr>
           <a:xfrm>
-            <a:off x="8229600" y="1371600"/>
-            <a:ext cx="3611880" cy="640080"/>
+            <a:off x="6185846" y="1371600"/>
+            <a:ext cx="2592883" cy="640080"/>
           </a:xfrm>
           <a:prstGeom prst="rect">
             <a:avLst/>
@@ -8752,8 +8752,8 @@
         </p:nvSpPr>
         <p:spPr>
           <a:xfrm>
-            <a:off x="8229600" y="1426464"/>
-            <a:ext cx="3611880" cy="548640"/>
+            <a:off x="6185846" y="1426464"/>
+            <a:ext cx="2592883" cy="548640"/>
           </a:xfrm>
           <a:prstGeom prst="rect">
             <a:avLst/>
@@ -8787,8 +8787,8 @@
         </p:nvSpPr>
         <p:spPr>
           <a:xfrm>
-            <a:off x="8229600" y="2057400"/>
-            <a:ext cx="3611880" cy="365760"/>
+            <a:off x="6185846" y="2057400"/>
+            <a:ext cx="2592883" cy="365760"/>
           </a:xfrm>
           <a:prstGeom prst="rect">
             <a:avLst/>
@@ -8822,8 +8822,8 @@
         </p:nvSpPr>
         <p:spPr>
           <a:xfrm>
-            <a:off x="8366760" y="2560320"/>
-            <a:ext cx="3337560" cy="3657600"/>
+            <a:off x="6323006" y="2560320"/>
+            <a:ext cx="2318563" cy="3657600"/>
           </a:xfrm>
           <a:prstGeom prst="rect">
             <a:avLst/>
@@ -8880,7 +8880,7 @@
                 </a:solidFill>
                 <a:latin typeface="Calibri"/>
               </a:rPr>
-              <a:t>• File attachments</a:t>
+              <a:t>• File / screenshot attachments</a:t>
             </a:r>
           </a:p>
           <a:p>
@@ -8967,6 +8967,255 @@
                 <a:latin typeface="Calibri"/>
               </a:rPr>
               <a:t>6</a:t>
+            </a:r>
+          </a:p>
+        </p:txBody>
+      </p:sp>
+      <p:sp>
+        <p:nvSpPr>
+          <p:cNvPr id="14" name="Rectangle 13"/>
+          <p:cNvSpPr/>
+          <p:nvPr/>
+        </p:nvSpPr>
+        <p:spPr>
+          <a:xfrm>
+            <a:off x="8958729" y="1371600"/>
+            <a:ext cx="2592883" cy="640080"/>
+          </a:xfrm>
+          <a:prstGeom prst="rect">
+            <a:avLst/>
+          </a:prstGeom>
+          <a:solidFill>
+            <a:srgbClr val="5B6473"/>
+          </a:solidFill>
+          <a:ln>
+            <a:noFill/>
+          </a:ln>
+          <a:effectLst/>
+        </p:spPr>
+        <p:style>
+          <a:lnRef idx="1">
+            <a:schemeClr val="accent1"/>
+          </a:lnRef>
+          <a:fillRef idx="3">
+            <a:schemeClr val="accent1"/>
+          </a:fillRef>
+          <a:effectRef idx="2">
+            <a:schemeClr val="accent1"/>
+          </a:effectRef>
+          <a:fontRef idx="minor">
+            <a:schemeClr val="lt1"/>
+          </a:fontRef>
+        </p:style>
+        <p:txBody>
+          <a:bodyPr rtlCol="0" anchor="ctr"/>
+          <a:lstStyle/>
+          <a:p>
+            <a:pPr algn="ctr"/>
+          </a:p>
+        </p:txBody>
+      </p:sp>
+      <p:sp>
+        <p:nvSpPr>
+          <p:cNvPr id="15" name="TextBox 14"/>
+          <p:cNvSpPr txBox="1"/>
+          <p:nvPr/>
+        </p:nvSpPr>
+        <p:spPr>
+          <a:xfrm>
+            <a:off x="8958729" y="1426464"/>
+            <a:ext cx="2592883" cy="548640"/>
+          </a:xfrm>
+          <a:prstGeom prst="rect">
+            <a:avLst/>
+          </a:prstGeom>
+          <a:noFill/>
+        </p:spPr>
+        <p:txBody>
+          <a:bodyPr wrap="square" anchor="t">
+            <a:spAutoFit/>
+          </a:bodyPr>
+          <a:lstStyle/>
+          <a:p>
+            <a:pPr algn="ctr"/>
+            <a:r>
+              <a:rPr sz="2000" b="1" i="0">
+                <a:solidFill>
+                  <a:srgbClr val="FFFFFF"/>
+                </a:solidFill>
+                <a:latin typeface="Calibri"/>
+              </a:rPr>
+              <a:t>FUTURE</a:t>
+            </a:r>
+          </a:p>
+        </p:txBody>
+      </p:sp>
+      <p:sp>
+        <p:nvSpPr>
+          <p:cNvPr id="16" name="TextBox 15"/>
+          <p:cNvSpPr txBox="1"/>
+          <p:nvPr/>
+        </p:nvSpPr>
+        <p:spPr>
+          <a:xfrm>
+            <a:off x="8958729" y="2057400"/>
+            <a:ext cx="2592883" cy="365760"/>
+          </a:xfrm>
+          <a:prstGeom prst="rect">
+            <a:avLst/>
+          </a:prstGeom>
+          <a:noFill/>
+        </p:spPr>
+        <p:txBody>
+          <a:bodyPr wrap="square" anchor="t">
+            <a:spAutoFit/>
+          </a:bodyPr>
+          <a:lstStyle/>
+          <a:p>
+            <a:pPr algn="ctr"/>
+            <a:r>
+              <a:rPr sz="1300" b="0" i="1">
+                <a:solidFill>
+                  <a:srgbClr val="595959"/>
+                </a:solidFill>
+                <a:latin typeface="Calibri"/>
+              </a:rPr>
+              <a:t>Out of scope now — the roadmap</a:t>
+            </a:r>
+          </a:p>
+        </p:txBody>
+      </p:sp>
+      <p:sp>
+        <p:nvSpPr>
+          <p:cNvPr id="17" name="TextBox 16"/>
+          <p:cNvSpPr txBox="1"/>
+          <p:nvPr/>
+        </p:nvSpPr>
+        <p:spPr>
+          <a:xfrm>
+            <a:off x="9095889" y="2560320"/>
+            <a:ext cx="2318563" cy="3657600"/>
+          </a:xfrm>
+          <a:prstGeom prst="rect">
+            <a:avLst/>
+          </a:prstGeom>
+          <a:noFill/>
+        </p:spPr>
+        <p:txBody>
+          <a:bodyPr wrap="square">
+            <a:spAutoFit/>
+          </a:bodyPr>
+          <a:lstStyle/>
+          <a:p>
+            <a:pPr>
+              <a:spcAft>
+                <a:spcPts val="800"/>
+              </a:spcAft>
+            </a:pPr>
+            <a:r>
+              <a:rPr sz="1600" b="0">
+                <a:solidFill>
+                  <a:srgbClr val="1F3864"/>
+                </a:solidFill>
+                <a:latin typeface="Calibri"/>
+              </a:rPr>
+              <a:t>• VPD / RLS row security</a:t>
+            </a:r>
+          </a:p>
+          <a:p>
+            <a:pPr>
+              <a:spcAft>
+                <a:spcPts val="800"/>
+              </a:spcAft>
+            </a:pPr>
+            <a:r>
+              <a:rPr sz="1600" b="0">
+                <a:solidFill>
+                  <a:srgbClr val="1F3864"/>
+                </a:solidFill>
+                <a:latin typeface="Calibri"/>
+              </a:rPr>
+              <a:t>• Real SLA engine (timers)</a:t>
+            </a:r>
+          </a:p>
+          <a:p>
+            <a:pPr>
+              <a:spcAft>
+                <a:spcPts val="800"/>
+              </a:spcAft>
+            </a:pPr>
+            <a:r>
+              <a:rPr sz="1600" b="0">
+                <a:solidFill>
+                  <a:srgbClr val="1F3864"/>
+                </a:solidFill>
+                <a:latin typeface="Calibri"/>
+              </a:rPr>
+              <a:t>• Object-storage attachments</a:t>
+            </a:r>
+          </a:p>
+          <a:p>
+            <a:pPr>
+              <a:spcAft>
+                <a:spcPts val="800"/>
+              </a:spcAft>
+            </a:pPr>
+            <a:r>
+              <a:rPr sz="1600" b="0">
+                <a:solidFill>
+                  <a:srgbClr val="1F3864"/>
+                </a:solidFill>
+                <a:latin typeface="Calibri"/>
+              </a:rPr>
+              <a:t>• Project Lead role (is_lead)</a:t>
+            </a:r>
+          </a:p>
+          <a:p>
+            <a:pPr>
+              <a:spcAft>
+                <a:spcPts val="800"/>
+              </a:spcAft>
+            </a:pPr>
+            <a:r>
+              <a:rPr sz="1600" b="0">
+                <a:solidFill>
+                  <a:srgbClr val="1F3864"/>
+                </a:solidFill>
+                <a:latin typeface="Calibri"/>
+              </a:rPr>
+              <a:t>• Email-to-ticket intake</a:t>
+            </a:r>
+          </a:p>
+          <a:p>
+            <a:pPr>
+              <a:spcAft>
+                <a:spcPts val="800"/>
+              </a:spcAft>
+            </a:pPr>
+            <a:r>
+              <a:rPr sz="1600" b="0">
+                <a:solidFill>
+                  <a:srgbClr val="1F3864"/>
+                </a:solidFill>
+                <a:latin typeface="Calibri"/>
+              </a:rPr>
+              <a:t>• SSO / directory login</a:t>
+            </a:r>
+          </a:p>
+          <a:p>
+            <a:pPr>
+              <a:spcAft>
+                <a:spcPts val="800"/>
+              </a:spcAft>
+            </a:pPr>
+            <a:r>
+              <a:rPr sz="1600" b="0">
+                <a:solidFill>
+                  <a:srgbClr val="1F3864"/>
+                </a:solidFill>
+                <a:latin typeface="Calibri"/>
+              </a:rPr>
+              <a:t>• KB portal &amp; integrations</a:t>
             </a:r>
           </a:p>
         </p:txBody>

</xml_diff>

<commit_message>
docs: sync all artifacts — severity/priority split, SLA→SHOULD, decisions J/K, client assign
Promote SLA breach highlighting from COULD to SHOULD (9 total), add
decisions J (clients assign agents) and K (severity ≠ priority), update
FR-7/10/15/23, data model (8 tables with SLA_TARGETS), roles, and mockups.
All artifacts verified consistent with the brief.

Co-Authored-By: Claude Opus 4.6 (1M context) <noreply@anthropic.com>
</commit_message>
<xml_diff>
--- a/docs/Ticketing-Kickoff.pptx
+++ b/docs/Ticketing-Kickoff.pptx
@@ -8695,7 +8695,8 @@
                 </a:solidFill>
                 <a:latin typeface="Calibri"/>
               </a:rPr>
-              <a:t>• Escalate action</a:t>
+              <a:t>• Escalate action
+• SLA per severity (breach indicators)</a:t>
             </a:r>
           </a:p>
         </p:txBody>
@@ -8848,7 +8849,7 @@
                 </a:solidFill>
                 <a:latin typeface="Calibri"/>
               </a:rPr>
-              <a:t>• SLA highlight (no timers)</a:t>
+              <a:t/>
             </a:r>
           </a:p>
           <a:p>
@@ -8896,7 +8897,7 @@
                 </a:solidFill>
                 <a:latin typeface="Calibri"/>
               </a:rPr>
-              <a:t>• Knowledge base</a:t>
+              <a:t/>
             </a:r>
           </a:p>
         </p:txBody>

</xml_diff>

<commit_message>
docs: ITIL 4 alignment — reframe as production system, add FRs 30–34, add itil-advisor agent
Reframe project from hackathon prototype to production system (demo 16 Jul 2026).
Adopt ITIL 4 Incident + Service Request Management as guiding framework.
Add 5 ITIL-driven SHOULDs (ticket type, first-response tracking, SLA compliance
KPI, workload LOV, severity guidance), promote FR-22 to SHOULD, rename severity
Cosmetic→Low, reorganize FUTURE into ITIL P1–P4 production roadmap.
New itil-advisor agent for ongoing ITIL alignment review.
Scope: MUST=17, SHOULD=15, COULD=2. All artifacts synced and verified.

Co-Authored-By: Claude Opus 4.6 (1M context) <noreply@anthropic.com>
</commit_message>
<xml_diff>
--- a/docs/Ticketing-Kickoff.pptx
+++ b/docs/Ticketing-Kickoff.pptx
@@ -8696,7 +8696,13 @@
                 <a:latin typeface="Calibri"/>
               </a:rPr>
               <a:t>• Escalate action
-• SLA per severity (breach indicators)</a:t>
+• SLA per severity (breach indicators)
+• Status-change notifications (ITIL)
+• Ticket type: Incident / Service Request
+• First-response time tracking
+• SLA Compliance % KPI
+• Workload in assignment LOV
+• Severity guidance on create form</a:t>
             </a:r>
           </a:p>
         </p:txBody>
@@ -8810,7 +8816,7 @@
                 </a:solidFill>
                 <a:latin typeface="Calibri"/>
               </a:rPr>
-              <a:t>Only if ahead — don't commit</a:t>
+              <a:t>Only if ahead of schedule — don't commit</a:t>
             </a:r>
           </a:p>
         </p:txBody>
@@ -8932,7 +8938,7 @@
                 </a:solidFill>
                 <a:latin typeface="Calibri"/>
               </a:rPr>
-              <a:t>Service Desk Ticketing System  ·  APEX Hackathon</a:t>
+              <a:t>Service Desk Ticketing System  ·  APEX Service Desk</a:t>
             </a:r>
           </a:p>
         </p:txBody>
@@ -9081,7 +9087,7 @@
                 </a:solidFill>
                 <a:latin typeface="Calibri"/>
               </a:rPr>
-              <a:t>Out of scope now — the roadmap</a:t>
+              <a:t>Out of scope for demo — ITIL production roadmap</a:t>
             </a:r>
           </a:p>
         </p:txBody>

</xml_diff>

<commit_message>
docs: manager feedback — L1-L4 tiers, dept-scoped clients, per-company SLA, auto-escalation
5 changes from manager feedback (2026-07-02):
- Decision M: agents carry explicit L1-L4 tier (APP_USERS.tier), reversing "no level field"
- Decision L: clients assign L1 agents only (LOV filtered to tier='L1')
- Decision N: Client User sees department-scoped tickets (new DEPARTMENTS table, 9 tables)
- Decision G revised: "Reassign" = manual tier transfer (FR-26); "Escalation" = system-driven
  auto-action on SLA breach (FR-35, DBMS_SCHEDULER job) — terminology aligned with industry
- FR-23 updated: SLA per severity per company (company_id added to SLA_TARGETS)
Scope: MUST=17, SHOULD=16, COULD=2. All artifacts synced and verified.

Co-Authored-By: Claude Opus 4.6 (1M context) <noreply@anthropic.com>
</commit_message>
<xml_diff>
--- a/docs/Ticketing-Kickoff.pptx
+++ b/docs/Ticketing-Kickoff.pptx
@@ -8695,8 +8695,9 @@
                 </a:solidFill>
                 <a:latin typeface="Calibri"/>
               </a:rPr>
-              <a:t>• Escalate action
-• SLA per severity (breach indicators)
+              <a:t>• Reassign to higher tier (L1-L4)
+• Auto-escalation on SLA breach
+• SLA per severity per project (breach indicators)
 • Status-change notifications (ITIL)
 • Ticket type: Incident / Service Request
 • First-response time tracking

</xml_diff>

<commit_message>
feat(mockups): sync demo with latest brief — tiers, depts, ticket types, resolve dialog, SLA page
Align the interactive mockup with all brief changes since the last sync
(manager feedback + ITIL audit). Key updates:
- Severity "Cosmetic" → "Low"; agent tiers L1–L4; department scoping
- Ticket type (Incident / Service Request) — FR-30 MUST
- Resolve dialog with resolution code + summary — FR-36
- Close dialog restricted to client/admin with inline CSAT — FR-11/FR-27
- Triage gate: priority required before In Progress — FR-37
- Per-company SLA targets with escalation_pct — FR-23/FR-35
- First-response tracking — FR-31; SLA Compliance % KPI — FR-32
- Tier-filtered escalation LOV — FR-26; severity guidance — FR-34
- New Page 13: SLA Targets management (System Admin)
- localStorage v4→v5 (reset required to pick up new seed data)

Co-Authored-By: Claude Opus 4.6 (1M context) <noreply@anthropic.com>
</commit_message>
<xml_diff>
--- a/docs/Ticketing-Kickoff.pptx
+++ b/docs/Ticketing-Kickoff.pptx
@@ -8433,6 +8433,22 @@
               <a:t>• Dashboard</a:t>
             </a:r>
           </a:p>
+          <a:p>
+            <a:pPr>
+              <a:spcAft>
+                <a:spcPts val="800"/>
+              </a:spcAft>
+            </a:pPr>
+            <a:r>
+              <a:rPr sz="1600" b="0">
+                <a:solidFill>
+                  <a:srgbClr val="1F3864"/>
+                </a:solidFill>
+                <a:latin typeface="Calibri"/>
+              </a:rPr>
+              <a:t>• Ticket type: Incident / Service Request</a:t>
+            </a:r>
+          </a:p>
         </p:txBody>
       </p:sp>
       <p:sp>
@@ -8696,10 +8712,10 @@
                 <a:latin typeface="Calibri"/>
               </a:rPr>
               <a:t>• Reassign to higher tier (L1-L4)
-• Auto-escalation on SLA breach
+• Auto-escalation on SLA breach (two-stage, per-company threshold, ITIL 4)
 • SLA per severity per project (breach indicators)
 • Status-change notifications (ITIL)
-• Ticket type: Incident / Service Request
+• Resolution code + summary on Resolve\n• Triage gate (priority before In Progress)
 • First-response time tracking
 • SLA Compliance % KPI
 • Workload in assignment LOV

</xml_diff>

<commit_message>
feat: add projects layer, role switching, new mockup pages + schema updates
Introduce PROJECTS table between COMPANIES and TICKETS (decision O),
USER_ROLES for multi-role switching (decision P), AGENT_PROJECTS and
USER_PROJECTS scoping. Add mockup pages 11/17/18, update schema/seed/views,
sync brief + all docs artifacts.

Co-Authored-By: Claude Opus 4.6 (1M context) <noreply@anthropic.com>
</commit_message>
<xml_diff>
--- a/docs/Ticketing-Kickoff.pptx
+++ b/docs/Ticketing-Kickoff.pptx
@@ -8350,7 +8350,7 @@
                 </a:solidFill>
                 <a:latin typeface="Calibri"/>
               </a:rPr>
-              <a:t>• Companies + users + roles</a:t>
+              <a:t>• Companies + projects + users + roles</a:t>
             </a:r>
           </a:p>
           <a:p>
@@ -8712,7 +8712,7 @@
                 <a:latin typeface="Calibri"/>
               </a:rPr>
               <a:t>• Reassign to higher tier (L1-L4)
-• Auto-escalation on SLA breach (two-stage, per-company threshold, ITIL 4)
+• Auto-escalation on SLA breach (two-stage, per-project threshold, ITIL 4)
 • SLA per severity per project (breach indicators)
 • Status-change notifications (ITIL)
 • Resolution code + summary on Resolve\n• Triage gate (priority before In Progress)

</xml_diff>

<commit_message>
docs: sync scope — 15 tables, FR-25 attachments built (MUST18/SHOULD19/COULD1)
- brief: FR-25 COULD->SHOULD (built 2026-07-05); ADMIN_AUDIT_LOG +
  TICKET_ATTACHMENTS in data model + ERD; AI (FR-24) stays COULD, blocked
  (every Generative AI provider needs an API key we don't have)
- HTML / XLSX / PPTX slide 6 / CLAUDE.md propagated; sync_docs verify = OK
</commit_message>
<xml_diff>
--- a/docs/Ticketing-Kickoff.pptx
+++ b/docs/Ticketing-Kickoff.pptx
@@ -8719,7 +8719,9 @@
 • First-response time tracking
 • SLA Compliance % KPI
 • Workload in assignment LOV
-• Severity guidance on create form</a:t>
+• Severity guidance on create form
+• File / screenshot attachments
+</a:t>
             </a:r>
           </a:p>
         </p:txBody>
@@ -8904,7 +8906,7 @@
                 </a:solidFill>
                 <a:latin typeface="Calibri"/>
               </a:rPr>
-              <a:t>• File / screenshot attachments</a:t>
+              <a:t/>
             </a:r>
           </a:p>
           <a:p>

</xml_diff>